<commit_message>
Slides: fix slide 8 claim, slide 3 overflow, add significance; write-up: 2-decimal ablation
</commit_message>
<xml_diff>
--- a/results/slides.pptx
+++ b/results/slides.pptx
@@ -1213,7 +1213,7 @@
           <a:lstStyle/>
           <a:p>
             <a:r>
-              <a:t>Adding the NB feature lifts every model. Top models are close, so features matter more than the model.</a:t>
+              <a:t>Adding the NB feature lifts every model by about a point. Gradient boosting still leads the next-best model by about two points, and the paired significance test confirms that lead is real, so both the feature and the model choice matter here.</a:t>
             </a:r>
           </a:p>
         </p:txBody>
@@ -4849,7 +4849,23 @@
                 </a:solidFill>
                 <a:latin typeface="Calibri"/>
               </a:rPr>
-              <a:t>Out-of-fold Naive-Bayes blurb probability is the main text feature (+0.84 pts); sentiment adds -0.03 pts, LDA +0.53 and LSA +0.56.</a:t>
+              <a:t>Out-of-fold Naive-Bayes blurb probability is the main text feature (+0.84 pts); sentiment adds −0.03 pts, LDA +0.53 and LSA +0.56.</a:t>
+            </a:r>
+          </a:p>
+          <a:p>
+            <a:pPr algn="l">
+              <a:spcBef>
+                <a:spcPts val="990"/>
+              </a:spcBef>
+            </a:pPr>
+            <a:r>
+              <a:rPr sz="2200" b="0">
+                <a:solidFill>
+                  <a:srgbClr val="FFFFFF"/>
+                </a:solidFill>
+                <a:latin typeface="Calibri"/>
+              </a:rPr>
+              <a:t>Paired significance tests: NB, LDA and LSA gains significant; sentiment not significant. Gradient boosting's lead over each other model is significant.</a:t>
             </a:r>
           </a:p>
           <a:p>
@@ -5627,7 +5643,7 @@
           <a:p>
             <a:pPr algn="l"/>
             <a:r>
-              <a:rPr sz="3000" b="1">
+              <a:rPr sz="2200" b="1">
                 <a:solidFill>
                   <a:srgbClr val="05A862"/>
                 </a:solidFill>
@@ -8891,7 +8907,7 @@
                 </a:solidFill>
                 <a:latin typeface="Calibri"/>
               </a:rPr>
-              <a:t>Features matter more than the model</a:t>
+              <a:t>The NB feature lifts every model</a:t>
             </a:r>
           </a:p>
         </p:txBody>
@@ -8926,7 +8942,7 @@
                 </a:solidFill>
                 <a:latin typeface="Calibri"/>
               </a:rPr>
-              <a:t>NB feature: 80.9% → 81.8% accuracy (+0.8 pts, LightGBM)</a:t>
+              <a:t>NB feature: 80.9% → 81.8% accuracy (+0.8 pts, LightGBM); G. Boosting leads the next model by 2.0 pts</a:t>
             </a:r>
           </a:p>
         </p:txBody>
@@ -9075,6 +9091,41 @@
           </a:prstGeom>
         </p:spPr>
       </p:pic>
+      <p:sp>
+        <p:nvSpPr>
+          <p:cNvPr id="5" name="TextBox 4"/>
+          <p:cNvSpPr txBox="1"/>
+          <p:nvPr/>
+        </p:nvSpPr>
+        <p:spPr>
+          <a:xfrm>
+            <a:off x="640080" y="6080760"/>
+            <a:ext cx="10881360" cy="640080"/>
+          </a:xfrm>
+          <a:prstGeom prst="rect">
+            <a:avLst/>
+          </a:prstGeom>
+          <a:noFill/>
+        </p:spPr>
+        <p:txBody>
+          <a:bodyPr wrap="square" anchor="t" lIns="0" rIns="0" tIns="0" bIns="0">
+            <a:spAutoFit/>
+          </a:bodyPr>
+          <a:lstStyle/>
+          <a:p>
+            <a:pPr algn="l"/>
+            <a:r>
+              <a:rPr sz="1300" b="0">
+                <a:solidFill>
+                  <a:srgbClr val="5E6B65"/>
+                </a:solidFill>
+                <a:latin typeface="Calibri"/>
+              </a:rPr>
+              <a:t>Paired bootstrap on the same test rows (95% CI): NB, LDA and LSA gains significant; sentiment not significant. Gradient boosting's lead over every other model is significant.</a:t>
+            </a:r>
+          </a:p>
+        </p:txBody>
+      </p:sp>
     </p:spTree>
   </p:cSld>
   <p:clrMapOvr>

</xml_diff>